<commit_message>
theme fillRef/bgRef (texture nen), them test deck_extras va README
Co-Authored-By: Claude Sonnet 5.5 <noreply@anthropic.com>
</commit_message>
<xml_diff>
--- a/packages/pptx_reader/test/fixtures/real/deck_16x9.pptx
+++ b/packages/pptx_reader/test/fixtures/real/deck_16x9.pptx
@@ -209,7 +209,7 @@
           </c:val>
           <c:extLst>
             <c:ext xmlns:c16="http://schemas.microsoft.com/office/drawing/2014/chart" uri="{C3380CC4-5D6E-409C-BE32-E72D297353CC}">
-              <c16:uniqueId val="{00000000-50B2-44E5-9BC4-CF28E916C96A}"/>
+              <c16:uniqueId val="{00000000-8A64-4DEF-8FED-DE6943114543}"/>
             </c:ext>
           </c:extLst>
         </c:ser>
@@ -280,7 +280,7 @@
           </c:val>
           <c:extLst>
             <c:ext xmlns:c16="http://schemas.microsoft.com/office/drawing/2014/chart" uri="{C3380CC4-5D6E-409C-BE32-E72D297353CC}">
-              <c16:uniqueId val="{00000001-50B2-44E5-9BC4-CF28E916C96A}"/>
+              <c16:uniqueId val="{00000001-8A64-4DEF-8FED-DE6943114543}"/>
             </c:ext>
           </c:extLst>
         </c:ser>
@@ -351,7 +351,7 @@
           </c:val>
           <c:extLst>
             <c:ext xmlns:c16="http://schemas.microsoft.com/office/drawing/2014/chart" uri="{C3380CC4-5D6E-409C-BE32-E72D297353CC}">
-              <c16:uniqueId val="{00000002-50B2-44E5-9BC4-CF28E916C96A}"/>
+              <c16:uniqueId val="{00000002-8A64-4DEF-8FED-DE6943114543}"/>
             </c:ext>
           </c:extLst>
         </c:ser>
@@ -365,11 +365,11 @@
         </c:dLbls>
         <c:gapWidth val="219"/>
         <c:overlap val="-27"/>
-        <c:axId val="571899824"/>
-        <c:axId val="571908944"/>
+        <c:axId val="1975293408"/>
+        <c:axId val="1975291488"/>
       </c:barChart>
       <c:catAx>
-        <c:axId val="571899824"/>
+        <c:axId val="1975293408"/>
         <c:scaling>
           <c:orientation val="minMax"/>
         </c:scaling>
@@ -412,7 +412,7 @@
             <a:endParaRPr lang="en-US"/>
           </a:p>
         </c:txPr>
-        <c:crossAx val="571908944"/>
+        <c:crossAx val="1975291488"/>
         <c:crosses val="autoZero"/>
         <c:auto val="1"/>
         <c:lblAlgn val="ctr"/>
@@ -420,7 +420,7 @@
         <c:noMultiLvlLbl val="0"/>
       </c:catAx>
       <c:valAx>
-        <c:axId val="571908944"/>
+        <c:axId val="1975291488"/>
         <c:scaling>
           <c:orientation val="minMax"/>
         </c:scaling>
@@ -471,7 +471,7 @@
             <a:endParaRPr lang="en-US"/>
           </a:p>
         </c:txPr>
-        <c:crossAx val="571899824"/>
+        <c:crossAx val="1975293408"/>
         <c:crosses val="autoZero"/>
         <c:crossBetween val="between"/>
       </c:valAx>
@@ -1171,7 +1171,7 @@
             </a:lvl1pPr>
           </a:lstStyle>
           <a:p>
-            <a:fld id="{A84A4FA0-6F55-419F-AA71-8E2985ACDA96}" type="datetimeFigureOut">
+            <a:fld id="{1CD1DA51-233C-4C9D-BC47-A23C3A53D278}" type="datetimeFigureOut">
               <a:rPr lang="en-US" smtClean="0"/>
               <a:t>10/26/2026</a:t>
             </a:fld>
@@ -1329,7 +1329,7 @@
             </a:lvl1pPr>
           </a:lstStyle>
           <a:p>
-            <a:fld id="{11171561-9B72-4124-BAEA-01BA8CB2C3D2}" type="slidenum">
+            <a:fld id="{EE9F5DE5-B1C5-423F-9129-1889EE5F0971}" type="slidenum">
               <a:rPr lang="en-US" smtClean="0"/>
               <a:t>‹#›</a:t>
             </a:fld>
@@ -1340,7 +1340,7 @@
     </p:spTree>
     <p:extLst>
       <p:ext uri="{BB962C8B-B14F-4D97-AF65-F5344CB8AC3E}">
-        <p14:creationId xmlns:p14="http://schemas.microsoft.com/office/powerpoint/2010/main" val="3651752380"/>
+        <p14:creationId xmlns:p14="http://schemas.microsoft.com/office/powerpoint/2010/main" val="2568665121"/>
       </p:ext>
     </p:extLst>
   </p:cSld>
@@ -1512,7 +1512,7 @@
           <a:bodyPr/>
           <a:lstStyle/>
           <a:p>
-            <a:fld id="{11171561-9B72-4124-BAEA-01BA8CB2C3D2}" type="slidenum">
+            <a:fld id="{EE9F5DE5-B1C5-423F-9129-1889EE5F0971}" type="slidenum">
               <a:rPr lang="en-US" smtClean="0"/>
               <a:t>9</a:t>
             </a:fld>
@@ -1523,7 +1523,7 @@
     </p:spTree>
     <p:extLst>
       <p:ext uri="{BB962C8B-B14F-4D97-AF65-F5344CB8AC3E}">
-        <p14:creationId xmlns:p14="http://schemas.microsoft.com/office/powerpoint/2010/main" val="2761076707"/>
+        <p14:creationId xmlns:p14="http://schemas.microsoft.com/office/powerpoint/2010/main" val="2026844217"/>
       </p:ext>
     </p:extLst>
   </p:cSld>
@@ -1555,7 +1555,7 @@
           <p:cNvPr id="2" name="Title 1">
             <a:extLst>
               <a:ext uri="{FF2B5EF4-FFF2-40B4-BE49-F238E27FC236}">
-                <a16:creationId xmlns:a16="http://schemas.microsoft.com/office/drawing/2014/main" id="{340FB678-D55A-BD73-E9A1-38270FD5A248}"/>
+                <a16:creationId xmlns:a16="http://schemas.microsoft.com/office/drawing/2014/main" id="{612E6217-269E-805B-317B-BE695FB51F80}"/>
               </a:ext>
             </a:extLst>
           </p:cNvPr>
@@ -1592,7 +1592,7 @@
           <p:cNvPr id="3" name="Subtitle 2">
             <a:extLst>
               <a:ext uri="{FF2B5EF4-FFF2-40B4-BE49-F238E27FC236}">
-                <a16:creationId xmlns:a16="http://schemas.microsoft.com/office/drawing/2014/main" id="{1DFA6D49-DB86-7B88-FF29-3F7778057E78}"/>
+                <a16:creationId xmlns:a16="http://schemas.microsoft.com/office/drawing/2014/main" id="{64C5ED21-A649-807E-0970-4187EEA6562D}"/>
               </a:ext>
             </a:extLst>
           </p:cNvPr>
@@ -1662,7 +1662,7 @@
           <p:cNvPr id="4" name="Date Placeholder 3">
             <a:extLst>
               <a:ext uri="{FF2B5EF4-FFF2-40B4-BE49-F238E27FC236}">
-                <a16:creationId xmlns:a16="http://schemas.microsoft.com/office/drawing/2014/main" id="{3D74CD8D-BA6D-4EE2-9D3F-5ADB73E148F9}"/>
+                <a16:creationId xmlns:a16="http://schemas.microsoft.com/office/drawing/2014/main" id="{5F02E003-1003-7ACA-6B0C-37121714995A}"/>
               </a:ext>
             </a:extLst>
           </p:cNvPr>
@@ -1678,7 +1678,7 @@
           <a:bodyPr/>
           <a:lstStyle/>
           <a:p>
-            <a:fld id="{68CF13B9-D35D-41F1-BDF9-F94BA176E306}" type="datetimeFigureOut">
+            <a:fld id="{1A83E605-C476-4F45-AFD5-5AA281B68665}" type="datetimeFigureOut">
               <a:rPr lang="en-US" smtClean="0"/>
               <a:t>10/26/2026</a:t>
             </a:fld>
@@ -1691,7 +1691,7 @@
           <p:cNvPr id="5" name="Footer Placeholder 4">
             <a:extLst>
               <a:ext uri="{FF2B5EF4-FFF2-40B4-BE49-F238E27FC236}">
-                <a16:creationId xmlns:a16="http://schemas.microsoft.com/office/drawing/2014/main" id="{BB024875-9F54-9C21-B7AE-D5BFAEAEA28B}"/>
+                <a16:creationId xmlns:a16="http://schemas.microsoft.com/office/drawing/2014/main" id="{2C795B27-2A13-6B71-15C0-A7EADA5B49FD}"/>
               </a:ext>
             </a:extLst>
           </p:cNvPr>
@@ -1716,7 +1716,7 @@
           <p:cNvPr id="6" name="Slide Number Placeholder 5">
             <a:extLst>
               <a:ext uri="{FF2B5EF4-FFF2-40B4-BE49-F238E27FC236}">
-                <a16:creationId xmlns:a16="http://schemas.microsoft.com/office/drawing/2014/main" id="{03123B83-E997-4E9C-6357-AF083838E268}"/>
+                <a16:creationId xmlns:a16="http://schemas.microsoft.com/office/drawing/2014/main" id="{F587D3A3-D5C0-7A26-03DE-6972222A1BDF}"/>
               </a:ext>
             </a:extLst>
           </p:cNvPr>
@@ -1732,7 +1732,7 @@
           <a:bodyPr/>
           <a:lstStyle/>
           <a:p>
-            <a:fld id="{3D843947-BC9A-457D-B935-8A90E729CDD9}" type="slidenum">
+            <a:fld id="{D1BC5639-7327-40EC-ADEE-32BCFEE5F9FC}" type="slidenum">
               <a:rPr lang="en-US" smtClean="0"/>
               <a:t>‹#›</a:t>
             </a:fld>
@@ -1743,7 +1743,7 @@
     </p:spTree>
     <p:extLst>
       <p:ext uri="{BB962C8B-B14F-4D97-AF65-F5344CB8AC3E}">
-        <p14:creationId xmlns:p14="http://schemas.microsoft.com/office/powerpoint/2010/main" val="352150413"/>
+        <p14:creationId xmlns:p14="http://schemas.microsoft.com/office/powerpoint/2010/main" val="3328154163"/>
       </p:ext>
     </p:extLst>
   </p:cSld>
@@ -1775,7 +1775,7 @@
           <p:cNvPr id="2" name="Title 1">
             <a:extLst>
               <a:ext uri="{FF2B5EF4-FFF2-40B4-BE49-F238E27FC236}">
-                <a16:creationId xmlns:a16="http://schemas.microsoft.com/office/drawing/2014/main" id="{D95117AF-222F-2E45-FD08-78997D4174A8}"/>
+                <a16:creationId xmlns:a16="http://schemas.microsoft.com/office/drawing/2014/main" id="{F780DA69-9539-7609-D233-FD842B1B1DD5}"/>
               </a:ext>
             </a:extLst>
           </p:cNvPr>
@@ -1803,7 +1803,7 @@
           <p:cNvPr id="3" name="Vertical Text Placeholder 2">
             <a:extLst>
               <a:ext uri="{FF2B5EF4-FFF2-40B4-BE49-F238E27FC236}">
-                <a16:creationId xmlns:a16="http://schemas.microsoft.com/office/drawing/2014/main" id="{99309EC5-6196-C104-1574-40EB10F02FA5}"/>
+                <a16:creationId xmlns:a16="http://schemas.microsoft.com/office/drawing/2014/main" id="{D26CB877-37CB-F93E-5255-FD31E6D6579B}"/>
               </a:ext>
             </a:extLst>
           </p:cNvPr>
@@ -1860,7 +1860,7 @@
           <p:cNvPr id="4" name="Date Placeholder 3">
             <a:extLst>
               <a:ext uri="{FF2B5EF4-FFF2-40B4-BE49-F238E27FC236}">
-                <a16:creationId xmlns:a16="http://schemas.microsoft.com/office/drawing/2014/main" id="{8C04EFFD-EEBB-5A96-43CA-34753B200892}"/>
+                <a16:creationId xmlns:a16="http://schemas.microsoft.com/office/drawing/2014/main" id="{16295BB3-7CDB-3FFE-A32F-A608555A0C8A}"/>
               </a:ext>
             </a:extLst>
           </p:cNvPr>
@@ -1876,7 +1876,7 @@
           <a:bodyPr/>
           <a:lstStyle/>
           <a:p>
-            <a:fld id="{68CF13B9-D35D-41F1-BDF9-F94BA176E306}" type="datetimeFigureOut">
+            <a:fld id="{1A83E605-C476-4F45-AFD5-5AA281B68665}" type="datetimeFigureOut">
               <a:rPr lang="en-US" smtClean="0"/>
               <a:t>10/26/2026</a:t>
             </a:fld>
@@ -1889,7 +1889,7 @@
           <p:cNvPr id="5" name="Footer Placeholder 4">
             <a:extLst>
               <a:ext uri="{FF2B5EF4-FFF2-40B4-BE49-F238E27FC236}">
-                <a16:creationId xmlns:a16="http://schemas.microsoft.com/office/drawing/2014/main" id="{30CEB104-0CA8-A9D2-2FA8-6230A6FEFCBD}"/>
+                <a16:creationId xmlns:a16="http://schemas.microsoft.com/office/drawing/2014/main" id="{D9CC20BE-492F-4FA3-BACC-D46C0ED1B054}"/>
               </a:ext>
             </a:extLst>
           </p:cNvPr>
@@ -1914,7 +1914,7 @@
           <p:cNvPr id="6" name="Slide Number Placeholder 5">
             <a:extLst>
               <a:ext uri="{FF2B5EF4-FFF2-40B4-BE49-F238E27FC236}">
-                <a16:creationId xmlns:a16="http://schemas.microsoft.com/office/drawing/2014/main" id="{AEE2AF92-5B31-B092-1320-EE300B299922}"/>
+                <a16:creationId xmlns:a16="http://schemas.microsoft.com/office/drawing/2014/main" id="{411A3163-7311-31B2-510B-E55F8855B3DF}"/>
               </a:ext>
             </a:extLst>
           </p:cNvPr>
@@ -1930,7 +1930,7 @@
           <a:bodyPr/>
           <a:lstStyle/>
           <a:p>
-            <a:fld id="{3D843947-BC9A-457D-B935-8A90E729CDD9}" type="slidenum">
+            <a:fld id="{D1BC5639-7327-40EC-ADEE-32BCFEE5F9FC}" type="slidenum">
               <a:rPr lang="en-US" smtClean="0"/>
               <a:t>‹#›</a:t>
             </a:fld>
@@ -1941,7 +1941,7 @@
     </p:spTree>
     <p:extLst>
       <p:ext uri="{BB962C8B-B14F-4D97-AF65-F5344CB8AC3E}">
-        <p14:creationId xmlns:p14="http://schemas.microsoft.com/office/powerpoint/2010/main" val="2549367509"/>
+        <p14:creationId xmlns:p14="http://schemas.microsoft.com/office/powerpoint/2010/main" val="2536885803"/>
       </p:ext>
     </p:extLst>
   </p:cSld>
@@ -1973,7 +1973,7 @@
           <p:cNvPr id="2" name="Vertical Title 1">
             <a:extLst>
               <a:ext uri="{FF2B5EF4-FFF2-40B4-BE49-F238E27FC236}">
-                <a16:creationId xmlns:a16="http://schemas.microsoft.com/office/drawing/2014/main" id="{859933DA-7F62-1642-F1EB-8DB3CE7B3808}"/>
+                <a16:creationId xmlns:a16="http://schemas.microsoft.com/office/drawing/2014/main" id="{FAE157D5-5CF6-1C1D-48C9-FBB9003A6ED3}"/>
               </a:ext>
             </a:extLst>
           </p:cNvPr>
@@ -2006,7 +2006,7 @@
           <p:cNvPr id="3" name="Vertical Text Placeholder 2">
             <a:extLst>
               <a:ext uri="{FF2B5EF4-FFF2-40B4-BE49-F238E27FC236}">
-                <a16:creationId xmlns:a16="http://schemas.microsoft.com/office/drawing/2014/main" id="{829C889E-072A-A16A-BA7D-EF386067C76E}"/>
+                <a16:creationId xmlns:a16="http://schemas.microsoft.com/office/drawing/2014/main" id="{356259A7-8ACF-B25E-04A4-89D6D67DBD30}"/>
               </a:ext>
             </a:extLst>
           </p:cNvPr>
@@ -2068,7 +2068,7 @@
           <p:cNvPr id="4" name="Date Placeholder 3">
             <a:extLst>
               <a:ext uri="{FF2B5EF4-FFF2-40B4-BE49-F238E27FC236}">
-                <a16:creationId xmlns:a16="http://schemas.microsoft.com/office/drawing/2014/main" id="{8D05F6DD-BC9F-5323-BE5C-A3978E1DD608}"/>
+                <a16:creationId xmlns:a16="http://schemas.microsoft.com/office/drawing/2014/main" id="{12BF48B8-78A7-521C-AC20-020101126886}"/>
               </a:ext>
             </a:extLst>
           </p:cNvPr>
@@ -2084,7 +2084,7 @@
           <a:bodyPr/>
           <a:lstStyle/>
           <a:p>
-            <a:fld id="{68CF13B9-D35D-41F1-BDF9-F94BA176E306}" type="datetimeFigureOut">
+            <a:fld id="{1A83E605-C476-4F45-AFD5-5AA281B68665}" type="datetimeFigureOut">
               <a:rPr lang="en-US" smtClean="0"/>
               <a:t>10/26/2026</a:t>
             </a:fld>
@@ -2097,7 +2097,7 @@
           <p:cNvPr id="5" name="Footer Placeholder 4">
             <a:extLst>
               <a:ext uri="{FF2B5EF4-FFF2-40B4-BE49-F238E27FC236}">
-                <a16:creationId xmlns:a16="http://schemas.microsoft.com/office/drawing/2014/main" id="{61E69273-21D5-A81C-C33B-2A10A4F28576}"/>
+                <a16:creationId xmlns:a16="http://schemas.microsoft.com/office/drawing/2014/main" id="{2C8DE5F6-8622-1A24-3215-B35DE7A5C9FF}"/>
               </a:ext>
             </a:extLst>
           </p:cNvPr>
@@ -2122,7 +2122,7 @@
           <p:cNvPr id="6" name="Slide Number Placeholder 5">
             <a:extLst>
               <a:ext uri="{FF2B5EF4-FFF2-40B4-BE49-F238E27FC236}">
-                <a16:creationId xmlns:a16="http://schemas.microsoft.com/office/drawing/2014/main" id="{B3F083DF-40AB-57AA-25F4-AAE4E2A94F72}"/>
+                <a16:creationId xmlns:a16="http://schemas.microsoft.com/office/drawing/2014/main" id="{1E413F0F-BCB8-2456-77C3-1B7450650D91}"/>
               </a:ext>
             </a:extLst>
           </p:cNvPr>
@@ -2138,7 +2138,7 @@
           <a:bodyPr/>
           <a:lstStyle/>
           <a:p>
-            <a:fld id="{3D843947-BC9A-457D-B935-8A90E729CDD9}" type="slidenum">
+            <a:fld id="{D1BC5639-7327-40EC-ADEE-32BCFEE5F9FC}" type="slidenum">
               <a:rPr lang="en-US" smtClean="0"/>
               <a:t>‹#›</a:t>
             </a:fld>
@@ -2149,7 +2149,7 @@
     </p:spTree>
     <p:extLst>
       <p:ext uri="{BB962C8B-B14F-4D97-AF65-F5344CB8AC3E}">
-        <p14:creationId xmlns:p14="http://schemas.microsoft.com/office/powerpoint/2010/main" val="153753594"/>
+        <p14:creationId xmlns:p14="http://schemas.microsoft.com/office/powerpoint/2010/main" val="11411319"/>
       </p:ext>
     </p:extLst>
   </p:cSld>
@@ -2181,7 +2181,7 @@
           <p:cNvPr id="2" name="Title 1">
             <a:extLst>
               <a:ext uri="{FF2B5EF4-FFF2-40B4-BE49-F238E27FC236}">
-                <a16:creationId xmlns:a16="http://schemas.microsoft.com/office/drawing/2014/main" id="{6C9032B8-5B64-E3F0-3B31-0649A4ED2057}"/>
+                <a16:creationId xmlns:a16="http://schemas.microsoft.com/office/drawing/2014/main" id="{AA25762D-0B78-B14D-6A08-70B8753724F7}"/>
               </a:ext>
             </a:extLst>
           </p:cNvPr>
@@ -2209,7 +2209,7 @@
           <p:cNvPr id="3" name="Content Placeholder 2">
             <a:extLst>
               <a:ext uri="{FF2B5EF4-FFF2-40B4-BE49-F238E27FC236}">
-                <a16:creationId xmlns:a16="http://schemas.microsoft.com/office/drawing/2014/main" id="{1B4068BE-CD3E-380E-1915-8EA0B8BF70D3}"/>
+                <a16:creationId xmlns:a16="http://schemas.microsoft.com/office/drawing/2014/main" id="{AA549931-3B90-EFF3-E444-00323DB06B62}"/>
               </a:ext>
             </a:extLst>
           </p:cNvPr>
@@ -2266,7 +2266,7 @@
           <p:cNvPr id="4" name="Date Placeholder 3">
             <a:extLst>
               <a:ext uri="{FF2B5EF4-FFF2-40B4-BE49-F238E27FC236}">
-                <a16:creationId xmlns:a16="http://schemas.microsoft.com/office/drawing/2014/main" id="{771604FE-270B-0C52-ED5C-81DAB5CE521E}"/>
+                <a16:creationId xmlns:a16="http://schemas.microsoft.com/office/drawing/2014/main" id="{5B04D9EA-E49B-6398-25F7-F23DB6C9D441}"/>
               </a:ext>
             </a:extLst>
           </p:cNvPr>
@@ -2282,7 +2282,7 @@
           <a:bodyPr/>
           <a:lstStyle/>
           <a:p>
-            <a:fld id="{68CF13B9-D35D-41F1-BDF9-F94BA176E306}" type="datetimeFigureOut">
+            <a:fld id="{1A83E605-C476-4F45-AFD5-5AA281B68665}" type="datetimeFigureOut">
               <a:rPr lang="en-US" smtClean="0"/>
               <a:t>10/26/2026</a:t>
             </a:fld>
@@ -2295,7 +2295,7 @@
           <p:cNvPr id="5" name="Footer Placeholder 4">
             <a:extLst>
               <a:ext uri="{FF2B5EF4-FFF2-40B4-BE49-F238E27FC236}">
-                <a16:creationId xmlns:a16="http://schemas.microsoft.com/office/drawing/2014/main" id="{F9EE62BA-FF76-B18A-8CD6-862E84D86E2F}"/>
+                <a16:creationId xmlns:a16="http://schemas.microsoft.com/office/drawing/2014/main" id="{4E712242-4F96-E293-AE30-EED35DEBBD36}"/>
               </a:ext>
             </a:extLst>
           </p:cNvPr>
@@ -2320,7 +2320,7 @@
           <p:cNvPr id="6" name="Slide Number Placeholder 5">
             <a:extLst>
               <a:ext uri="{FF2B5EF4-FFF2-40B4-BE49-F238E27FC236}">
-                <a16:creationId xmlns:a16="http://schemas.microsoft.com/office/drawing/2014/main" id="{D87D1346-FFCD-C74B-AE3B-EA8800FC4633}"/>
+                <a16:creationId xmlns:a16="http://schemas.microsoft.com/office/drawing/2014/main" id="{EC783E3B-835A-5314-5798-0B0217CF1EDA}"/>
               </a:ext>
             </a:extLst>
           </p:cNvPr>
@@ -2336,7 +2336,7 @@
           <a:bodyPr/>
           <a:lstStyle/>
           <a:p>
-            <a:fld id="{3D843947-BC9A-457D-B935-8A90E729CDD9}" type="slidenum">
+            <a:fld id="{D1BC5639-7327-40EC-ADEE-32BCFEE5F9FC}" type="slidenum">
               <a:rPr lang="en-US" smtClean="0"/>
               <a:t>‹#›</a:t>
             </a:fld>
@@ -2347,7 +2347,7 @@
     </p:spTree>
     <p:extLst>
       <p:ext uri="{BB962C8B-B14F-4D97-AF65-F5344CB8AC3E}">
-        <p14:creationId xmlns:p14="http://schemas.microsoft.com/office/powerpoint/2010/main" val="2303431364"/>
+        <p14:creationId xmlns:p14="http://schemas.microsoft.com/office/powerpoint/2010/main" val="2990604552"/>
       </p:ext>
     </p:extLst>
   </p:cSld>
@@ -2379,7 +2379,7 @@
           <p:cNvPr id="2" name="Title 1">
             <a:extLst>
               <a:ext uri="{FF2B5EF4-FFF2-40B4-BE49-F238E27FC236}">
-                <a16:creationId xmlns:a16="http://schemas.microsoft.com/office/drawing/2014/main" id="{EC7B1893-95A1-FA01-06C3-FFAD17992D76}"/>
+                <a16:creationId xmlns:a16="http://schemas.microsoft.com/office/drawing/2014/main" id="{EF04D49A-0947-916E-1A46-C6604E622D35}"/>
               </a:ext>
             </a:extLst>
           </p:cNvPr>
@@ -2416,7 +2416,7 @@
           <p:cNvPr id="3" name="Text Placeholder 2">
             <a:extLst>
               <a:ext uri="{FF2B5EF4-FFF2-40B4-BE49-F238E27FC236}">
-                <a16:creationId xmlns:a16="http://schemas.microsoft.com/office/drawing/2014/main" id="{3B9C0253-5100-604D-AAA7-B9CF55AAD2EF}"/>
+                <a16:creationId xmlns:a16="http://schemas.microsoft.com/office/drawing/2014/main" id="{5E876039-7CDE-7921-979D-0D69F6402310}"/>
               </a:ext>
             </a:extLst>
           </p:cNvPr>
@@ -2541,7 +2541,7 @@
           <p:cNvPr id="4" name="Date Placeholder 3">
             <a:extLst>
               <a:ext uri="{FF2B5EF4-FFF2-40B4-BE49-F238E27FC236}">
-                <a16:creationId xmlns:a16="http://schemas.microsoft.com/office/drawing/2014/main" id="{B48847DE-354C-C4B7-4997-BDFA234A5837}"/>
+                <a16:creationId xmlns:a16="http://schemas.microsoft.com/office/drawing/2014/main" id="{01349EF5-708B-5366-3660-DCCF139F44AF}"/>
               </a:ext>
             </a:extLst>
           </p:cNvPr>
@@ -2557,7 +2557,7 @@
           <a:bodyPr/>
           <a:lstStyle/>
           <a:p>
-            <a:fld id="{68CF13B9-D35D-41F1-BDF9-F94BA176E306}" type="datetimeFigureOut">
+            <a:fld id="{1A83E605-C476-4F45-AFD5-5AA281B68665}" type="datetimeFigureOut">
               <a:rPr lang="en-US" smtClean="0"/>
               <a:t>10/26/2026</a:t>
             </a:fld>
@@ -2570,7 +2570,7 @@
           <p:cNvPr id="5" name="Footer Placeholder 4">
             <a:extLst>
               <a:ext uri="{FF2B5EF4-FFF2-40B4-BE49-F238E27FC236}">
-                <a16:creationId xmlns:a16="http://schemas.microsoft.com/office/drawing/2014/main" id="{52AC2937-C5D4-B839-3C62-0894ABBC68E9}"/>
+                <a16:creationId xmlns:a16="http://schemas.microsoft.com/office/drawing/2014/main" id="{5E6FCBD5-AE0D-85B1-8B26-9304D13A9844}"/>
               </a:ext>
             </a:extLst>
           </p:cNvPr>
@@ -2595,7 +2595,7 @@
           <p:cNvPr id="6" name="Slide Number Placeholder 5">
             <a:extLst>
               <a:ext uri="{FF2B5EF4-FFF2-40B4-BE49-F238E27FC236}">
-                <a16:creationId xmlns:a16="http://schemas.microsoft.com/office/drawing/2014/main" id="{A913793B-30F1-3638-200D-DDAACEDFCFAE}"/>
+                <a16:creationId xmlns:a16="http://schemas.microsoft.com/office/drawing/2014/main" id="{382989EA-57CF-043C-5721-E358F9C7DCB0}"/>
               </a:ext>
             </a:extLst>
           </p:cNvPr>
@@ -2611,7 +2611,7 @@
           <a:bodyPr/>
           <a:lstStyle/>
           <a:p>
-            <a:fld id="{3D843947-BC9A-457D-B935-8A90E729CDD9}" type="slidenum">
+            <a:fld id="{D1BC5639-7327-40EC-ADEE-32BCFEE5F9FC}" type="slidenum">
               <a:rPr lang="en-US" smtClean="0"/>
               <a:t>‹#›</a:t>
             </a:fld>
@@ -2622,7 +2622,7 @@
     </p:spTree>
     <p:extLst>
       <p:ext uri="{BB962C8B-B14F-4D97-AF65-F5344CB8AC3E}">
-        <p14:creationId xmlns:p14="http://schemas.microsoft.com/office/powerpoint/2010/main" val="1925575585"/>
+        <p14:creationId xmlns:p14="http://schemas.microsoft.com/office/powerpoint/2010/main" val="2318557295"/>
       </p:ext>
     </p:extLst>
   </p:cSld>
@@ -2654,7 +2654,7 @@
           <p:cNvPr id="2" name="Title 1">
             <a:extLst>
               <a:ext uri="{FF2B5EF4-FFF2-40B4-BE49-F238E27FC236}">
-                <a16:creationId xmlns:a16="http://schemas.microsoft.com/office/drawing/2014/main" id="{B67AA978-5FE0-1E3E-F524-20AC831E0C19}"/>
+                <a16:creationId xmlns:a16="http://schemas.microsoft.com/office/drawing/2014/main" id="{1FEB3A3A-79FA-68DB-7D28-3F0FD396FDB9}"/>
               </a:ext>
             </a:extLst>
           </p:cNvPr>
@@ -2682,7 +2682,7 @@
           <p:cNvPr id="3" name="Content Placeholder 2">
             <a:extLst>
               <a:ext uri="{FF2B5EF4-FFF2-40B4-BE49-F238E27FC236}">
-                <a16:creationId xmlns:a16="http://schemas.microsoft.com/office/drawing/2014/main" id="{5CD9F0F6-8858-F4F1-E548-E35853856AD1}"/>
+                <a16:creationId xmlns:a16="http://schemas.microsoft.com/office/drawing/2014/main" id="{67C52A22-C69D-8B30-59C0-02400A43AE0D}"/>
               </a:ext>
             </a:extLst>
           </p:cNvPr>
@@ -2744,7 +2744,7 @@
           <p:cNvPr id="4" name="Content Placeholder 3">
             <a:extLst>
               <a:ext uri="{FF2B5EF4-FFF2-40B4-BE49-F238E27FC236}">
-                <a16:creationId xmlns:a16="http://schemas.microsoft.com/office/drawing/2014/main" id="{6097598E-8566-D67C-81C1-4500D389972A}"/>
+                <a16:creationId xmlns:a16="http://schemas.microsoft.com/office/drawing/2014/main" id="{2F146109-6838-EBF4-A32A-FF9DB25C3611}"/>
               </a:ext>
             </a:extLst>
           </p:cNvPr>
@@ -2806,7 +2806,7 @@
           <p:cNvPr id="5" name="Date Placeholder 4">
             <a:extLst>
               <a:ext uri="{FF2B5EF4-FFF2-40B4-BE49-F238E27FC236}">
-                <a16:creationId xmlns:a16="http://schemas.microsoft.com/office/drawing/2014/main" id="{8FCD2F6B-37BC-41D0-5796-9F8A872CE741}"/>
+                <a16:creationId xmlns:a16="http://schemas.microsoft.com/office/drawing/2014/main" id="{404C6D10-DC90-7E8D-75B8-42FD1D5E462F}"/>
               </a:ext>
             </a:extLst>
           </p:cNvPr>
@@ -2822,7 +2822,7 @@
           <a:bodyPr/>
           <a:lstStyle/>
           <a:p>
-            <a:fld id="{68CF13B9-D35D-41F1-BDF9-F94BA176E306}" type="datetimeFigureOut">
+            <a:fld id="{1A83E605-C476-4F45-AFD5-5AA281B68665}" type="datetimeFigureOut">
               <a:rPr lang="en-US" smtClean="0"/>
               <a:t>10/26/2026</a:t>
             </a:fld>
@@ -2835,7 +2835,7 @@
           <p:cNvPr id="6" name="Footer Placeholder 5">
             <a:extLst>
               <a:ext uri="{FF2B5EF4-FFF2-40B4-BE49-F238E27FC236}">
-                <a16:creationId xmlns:a16="http://schemas.microsoft.com/office/drawing/2014/main" id="{E8743643-C873-E2F0-75A4-FF5C64F15981}"/>
+                <a16:creationId xmlns:a16="http://schemas.microsoft.com/office/drawing/2014/main" id="{DDD0FD73-EBE1-A2AD-098E-125A076E8BE6}"/>
               </a:ext>
             </a:extLst>
           </p:cNvPr>
@@ -2860,7 +2860,7 @@
           <p:cNvPr id="7" name="Slide Number Placeholder 6">
             <a:extLst>
               <a:ext uri="{FF2B5EF4-FFF2-40B4-BE49-F238E27FC236}">
-                <a16:creationId xmlns:a16="http://schemas.microsoft.com/office/drawing/2014/main" id="{88CC52AB-B3EE-2394-EB05-C8802A42A393}"/>
+                <a16:creationId xmlns:a16="http://schemas.microsoft.com/office/drawing/2014/main" id="{A5CA924C-4856-6540-ADE9-4CE8E98BF3A8}"/>
               </a:ext>
             </a:extLst>
           </p:cNvPr>
@@ -2876,7 +2876,7 @@
           <a:bodyPr/>
           <a:lstStyle/>
           <a:p>
-            <a:fld id="{3D843947-BC9A-457D-B935-8A90E729CDD9}" type="slidenum">
+            <a:fld id="{D1BC5639-7327-40EC-ADEE-32BCFEE5F9FC}" type="slidenum">
               <a:rPr lang="en-US" smtClean="0"/>
               <a:t>‹#›</a:t>
             </a:fld>
@@ -2887,7 +2887,7 @@
     </p:spTree>
     <p:extLst>
       <p:ext uri="{BB962C8B-B14F-4D97-AF65-F5344CB8AC3E}">
-        <p14:creationId xmlns:p14="http://schemas.microsoft.com/office/powerpoint/2010/main" val="805663641"/>
+        <p14:creationId xmlns:p14="http://schemas.microsoft.com/office/powerpoint/2010/main" val="2113811617"/>
       </p:ext>
     </p:extLst>
   </p:cSld>
@@ -2919,7 +2919,7 @@
           <p:cNvPr id="2" name="Title 1">
             <a:extLst>
               <a:ext uri="{FF2B5EF4-FFF2-40B4-BE49-F238E27FC236}">
-                <a16:creationId xmlns:a16="http://schemas.microsoft.com/office/drawing/2014/main" id="{ADC6EC8F-23FD-CCEF-A604-B7E15A0C7FCD}"/>
+                <a16:creationId xmlns:a16="http://schemas.microsoft.com/office/drawing/2014/main" id="{6EA07209-C1FE-3317-A81A-1FCFF3BB3A13}"/>
               </a:ext>
             </a:extLst>
           </p:cNvPr>
@@ -2952,7 +2952,7 @@
           <p:cNvPr id="3" name="Text Placeholder 2">
             <a:extLst>
               <a:ext uri="{FF2B5EF4-FFF2-40B4-BE49-F238E27FC236}">
-                <a16:creationId xmlns:a16="http://schemas.microsoft.com/office/drawing/2014/main" id="{4D92E1A1-5A70-96EF-9688-1E03260368F4}"/>
+                <a16:creationId xmlns:a16="http://schemas.microsoft.com/office/drawing/2014/main" id="{F03C7698-EE12-0762-DD16-91F644D3D07B}"/>
               </a:ext>
             </a:extLst>
           </p:cNvPr>
@@ -3023,7 +3023,7 @@
           <p:cNvPr id="4" name="Content Placeholder 3">
             <a:extLst>
               <a:ext uri="{FF2B5EF4-FFF2-40B4-BE49-F238E27FC236}">
-                <a16:creationId xmlns:a16="http://schemas.microsoft.com/office/drawing/2014/main" id="{6225F78F-ACCB-1453-25CF-56EB89AA12B0}"/>
+                <a16:creationId xmlns:a16="http://schemas.microsoft.com/office/drawing/2014/main" id="{5489674D-CD0E-B6A5-F06A-F5D13C16666E}"/>
               </a:ext>
             </a:extLst>
           </p:cNvPr>
@@ -3085,7 +3085,7 @@
           <p:cNvPr id="5" name="Text Placeholder 4">
             <a:extLst>
               <a:ext uri="{FF2B5EF4-FFF2-40B4-BE49-F238E27FC236}">
-                <a16:creationId xmlns:a16="http://schemas.microsoft.com/office/drawing/2014/main" id="{F2883FEF-AAD2-3752-F643-26D3FDC91B1B}"/>
+                <a16:creationId xmlns:a16="http://schemas.microsoft.com/office/drawing/2014/main" id="{5726E9EA-926A-7788-10AC-475740A9FEC4}"/>
               </a:ext>
             </a:extLst>
           </p:cNvPr>
@@ -3156,7 +3156,7 @@
           <p:cNvPr id="6" name="Content Placeholder 5">
             <a:extLst>
               <a:ext uri="{FF2B5EF4-FFF2-40B4-BE49-F238E27FC236}">
-                <a16:creationId xmlns:a16="http://schemas.microsoft.com/office/drawing/2014/main" id="{C2B43630-E06B-BE2E-B2D4-86416CC30CD7}"/>
+                <a16:creationId xmlns:a16="http://schemas.microsoft.com/office/drawing/2014/main" id="{D49CABDC-D8DD-6730-033F-EA3DC6A36952}"/>
               </a:ext>
             </a:extLst>
           </p:cNvPr>
@@ -3218,7 +3218,7 @@
           <p:cNvPr id="7" name="Date Placeholder 6">
             <a:extLst>
               <a:ext uri="{FF2B5EF4-FFF2-40B4-BE49-F238E27FC236}">
-                <a16:creationId xmlns:a16="http://schemas.microsoft.com/office/drawing/2014/main" id="{D5A4B07A-D866-1F78-D950-54CD7B8B8EE4}"/>
+                <a16:creationId xmlns:a16="http://schemas.microsoft.com/office/drawing/2014/main" id="{D1C01E66-663F-A2CC-78A8-19485A68EAFE}"/>
               </a:ext>
             </a:extLst>
           </p:cNvPr>
@@ -3234,7 +3234,7 @@
           <a:bodyPr/>
           <a:lstStyle/>
           <a:p>
-            <a:fld id="{68CF13B9-D35D-41F1-BDF9-F94BA176E306}" type="datetimeFigureOut">
+            <a:fld id="{1A83E605-C476-4F45-AFD5-5AA281B68665}" type="datetimeFigureOut">
               <a:rPr lang="en-US" smtClean="0"/>
               <a:t>10/26/2026</a:t>
             </a:fld>
@@ -3247,7 +3247,7 @@
           <p:cNvPr id="8" name="Footer Placeholder 7">
             <a:extLst>
               <a:ext uri="{FF2B5EF4-FFF2-40B4-BE49-F238E27FC236}">
-                <a16:creationId xmlns:a16="http://schemas.microsoft.com/office/drawing/2014/main" id="{22CAD6C5-2BAF-3BF5-3F43-D95C65A60481}"/>
+                <a16:creationId xmlns:a16="http://schemas.microsoft.com/office/drawing/2014/main" id="{F508D139-33E8-0253-CE24-F47DFA27DA3B}"/>
               </a:ext>
             </a:extLst>
           </p:cNvPr>
@@ -3272,7 +3272,7 @@
           <p:cNvPr id="9" name="Slide Number Placeholder 8">
             <a:extLst>
               <a:ext uri="{FF2B5EF4-FFF2-40B4-BE49-F238E27FC236}">
-                <a16:creationId xmlns:a16="http://schemas.microsoft.com/office/drawing/2014/main" id="{10EF0008-6E3F-A677-32AF-AB22DE6BB8AD}"/>
+                <a16:creationId xmlns:a16="http://schemas.microsoft.com/office/drawing/2014/main" id="{710CDBD6-7806-0A68-D568-547E5A4EC983}"/>
               </a:ext>
             </a:extLst>
           </p:cNvPr>
@@ -3288,7 +3288,7 @@
           <a:bodyPr/>
           <a:lstStyle/>
           <a:p>
-            <a:fld id="{3D843947-BC9A-457D-B935-8A90E729CDD9}" type="slidenum">
+            <a:fld id="{D1BC5639-7327-40EC-ADEE-32BCFEE5F9FC}" type="slidenum">
               <a:rPr lang="en-US" smtClean="0"/>
               <a:t>‹#›</a:t>
             </a:fld>
@@ -3299,7 +3299,7 @@
     </p:spTree>
     <p:extLst>
       <p:ext uri="{BB962C8B-B14F-4D97-AF65-F5344CB8AC3E}">
-        <p14:creationId xmlns:p14="http://schemas.microsoft.com/office/powerpoint/2010/main" val="1127677129"/>
+        <p14:creationId xmlns:p14="http://schemas.microsoft.com/office/powerpoint/2010/main" val="2892460218"/>
       </p:ext>
     </p:extLst>
   </p:cSld>
@@ -3331,7 +3331,7 @@
           <p:cNvPr id="2" name="Title 1">
             <a:extLst>
               <a:ext uri="{FF2B5EF4-FFF2-40B4-BE49-F238E27FC236}">
-                <a16:creationId xmlns:a16="http://schemas.microsoft.com/office/drawing/2014/main" id="{867AC60E-29F0-729E-DDCA-0B45C8F7B8ED}"/>
+                <a16:creationId xmlns:a16="http://schemas.microsoft.com/office/drawing/2014/main" id="{C62FD803-8B8C-13A2-58EC-46043BE340B3}"/>
               </a:ext>
             </a:extLst>
           </p:cNvPr>
@@ -3359,7 +3359,7 @@
           <p:cNvPr id="3" name="Date Placeholder 2">
             <a:extLst>
               <a:ext uri="{FF2B5EF4-FFF2-40B4-BE49-F238E27FC236}">
-                <a16:creationId xmlns:a16="http://schemas.microsoft.com/office/drawing/2014/main" id="{33A4D484-EFE0-E993-CC30-AF1A70FF2563}"/>
+                <a16:creationId xmlns:a16="http://schemas.microsoft.com/office/drawing/2014/main" id="{73F33537-2EF5-9B46-FD35-ED72CA9C986A}"/>
               </a:ext>
             </a:extLst>
           </p:cNvPr>
@@ -3375,7 +3375,7 @@
           <a:bodyPr/>
           <a:lstStyle/>
           <a:p>
-            <a:fld id="{68CF13B9-D35D-41F1-BDF9-F94BA176E306}" type="datetimeFigureOut">
+            <a:fld id="{1A83E605-C476-4F45-AFD5-5AA281B68665}" type="datetimeFigureOut">
               <a:rPr lang="en-US" smtClean="0"/>
               <a:t>10/26/2026</a:t>
             </a:fld>
@@ -3388,7 +3388,7 @@
           <p:cNvPr id="4" name="Footer Placeholder 3">
             <a:extLst>
               <a:ext uri="{FF2B5EF4-FFF2-40B4-BE49-F238E27FC236}">
-                <a16:creationId xmlns:a16="http://schemas.microsoft.com/office/drawing/2014/main" id="{337BC0D2-1B66-7540-1A02-CDA6133C7708}"/>
+                <a16:creationId xmlns:a16="http://schemas.microsoft.com/office/drawing/2014/main" id="{7609CE21-9C49-8119-57F8-69545509503F}"/>
               </a:ext>
             </a:extLst>
           </p:cNvPr>
@@ -3413,7 +3413,7 @@
           <p:cNvPr id="5" name="Slide Number Placeholder 4">
             <a:extLst>
               <a:ext uri="{FF2B5EF4-FFF2-40B4-BE49-F238E27FC236}">
-                <a16:creationId xmlns:a16="http://schemas.microsoft.com/office/drawing/2014/main" id="{1122A118-6AF7-58B6-DA03-7AD61CE842EB}"/>
+                <a16:creationId xmlns:a16="http://schemas.microsoft.com/office/drawing/2014/main" id="{0EE4FA25-8FC5-BB2A-37F9-9D39BF4DACFE}"/>
               </a:ext>
             </a:extLst>
           </p:cNvPr>
@@ -3429,7 +3429,7 @@
           <a:bodyPr/>
           <a:lstStyle/>
           <a:p>
-            <a:fld id="{3D843947-BC9A-457D-B935-8A90E729CDD9}" type="slidenum">
+            <a:fld id="{D1BC5639-7327-40EC-ADEE-32BCFEE5F9FC}" type="slidenum">
               <a:rPr lang="en-US" smtClean="0"/>
               <a:t>‹#›</a:t>
             </a:fld>
@@ -3440,7 +3440,7 @@
     </p:spTree>
     <p:extLst>
       <p:ext uri="{BB962C8B-B14F-4D97-AF65-F5344CB8AC3E}">
-        <p14:creationId xmlns:p14="http://schemas.microsoft.com/office/powerpoint/2010/main" val="708735712"/>
+        <p14:creationId xmlns:p14="http://schemas.microsoft.com/office/powerpoint/2010/main" val="65362330"/>
       </p:ext>
     </p:extLst>
   </p:cSld>
@@ -3472,7 +3472,7 @@
           <p:cNvPr id="2" name="Date Placeholder 1">
             <a:extLst>
               <a:ext uri="{FF2B5EF4-FFF2-40B4-BE49-F238E27FC236}">
-                <a16:creationId xmlns:a16="http://schemas.microsoft.com/office/drawing/2014/main" id="{63E17305-30E6-4144-4A7C-0B4DB9AA914D}"/>
+                <a16:creationId xmlns:a16="http://schemas.microsoft.com/office/drawing/2014/main" id="{C6374CC2-1996-2AF2-0633-8BB0A8D43A29}"/>
               </a:ext>
             </a:extLst>
           </p:cNvPr>
@@ -3488,7 +3488,7 @@
           <a:bodyPr/>
           <a:lstStyle/>
           <a:p>
-            <a:fld id="{68CF13B9-D35D-41F1-BDF9-F94BA176E306}" type="datetimeFigureOut">
+            <a:fld id="{1A83E605-C476-4F45-AFD5-5AA281B68665}" type="datetimeFigureOut">
               <a:rPr lang="en-US" smtClean="0"/>
               <a:t>10/26/2026</a:t>
             </a:fld>
@@ -3501,7 +3501,7 @@
           <p:cNvPr id="3" name="Footer Placeholder 2">
             <a:extLst>
               <a:ext uri="{FF2B5EF4-FFF2-40B4-BE49-F238E27FC236}">
-                <a16:creationId xmlns:a16="http://schemas.microsoft.com/office/drawing/2014/main" id="{09A98532-6762-0BE4-8F75-6462874BB08E}"/>
+                <a16:creationId xmlns:a16="http://schemas.microsoft.com/office/drawing/2014/main" id="{B205809F-5A83-868F-2AEE-AF74A4BB0214}"/>
               </a:ext>
             </a:extLst>
           </p:cNvPr>
@@ -3526,7 +3526,7 @@
           <p:cNvPr id="4" name="Slide Number Placeholder 3">
             <a:extLst>
               <a:ext uri="{FF2B5EF4-FFF2-40B4-BE49-F238E27FC236}">
-                <a16:creationId xmlns:a16="http://schemas.microsoft.com/office/drawing/2014/main" id="{FDA936F3-1B09-5A70-FB78-9330404E6DFD}"/>
+                <a16:creationId xmlns:a16="http://schemas.microsoft.com/office/drawing/2014/main" id="{894DFCB9-F424-6037-9EC2-5FF3C5C66716}"/>
               </a:ext>
             </a:extLst>
           </p:cNvPr>
@@ -3542,7 +3542,7 @@
           <a:bodyPr/>
           <a:lstStyle/>
           <a:p>
-            <a:fld id="{3D843947-BC9A-457D-B935-8A90E729CDD9}" type="slidenum">
+            <a:fld id="{D1BC5639-7327-40EC-ADEE-32BCFEE5F9FC}" type="slidenum">
               <a:rPr lang="en-US" smtClean="0"/>
               <a:t>‹#›</a:t>
             </a:fld>
@@ -3553,7 +3553,7 @@
     </p:spTree>
     <p:extLst>
       <p:ext uri="{BB962C8B-B14F-4D97-AF65-F5344CB8AC3E}">
-        <p14:creationId xmlns:p14="http://schemas.microsoft.com/office/powerpoint/2010/main" val="2812143882"/>
+        <p14:creationId xmlns:p14="http://schemas.microsoft.com/office/powerpoint/2010/main" val="3198104749"/>
       </p:ext>
     </p:extLst>
   </p:cSld>
@@ -3585,7 +3585,7 @@
           <p:cNvPr id="2" name="Title 1">
             <a:extLst>
               <a:ext uri="{FF2B5EF4-FFF2-40B4-BE49-F238E27FC236}">
-                <a16:creationId xmlns:a16="http://schemas.microsoft.com/office/drawing/2014/main" id="{424098C5-42D5-3237-2F56-F8FB0445EC11}"/>
+                <a16:creationId xmlns:a16="http://schemas.microsoft.com/office/drawing/2014/main" id="{8D477A0F-FC86-CAB4-69D6-B25D98332374}"/>
               </a:ext>
             </a:extLst>
           </p:cNvPr>
@@ -3622,7 +3622,7 @@
           <p:cNvPr id="3" name="Content Placeholder 2">
             <a:extLst>
               <a:ext uri="{FF2B5EF4-FFF2-40B4-BE49-F238E27FC236}">
-                <a16:creationId xmlns:a16="http://schemas.microsoft.com/office/drawing/2014/main" id="{F0D4C89D-B5DB-AEF8-1A74-CE84092D113E}"/>
+                <a16:creationId xmlns:a16="http://schemas.microsoft.com/office/drawing/2014/main" id="{03805ED1-739C-F2A8-9B16-6D2D0C925FDB}"/>
               </a:ext>
             </a:extLst>
           </p:cNvPr>
@@ -3712,7 +3712,7 @@
           <p:cNvPr id="4" name="Text Placeholder 3">
             <a:extLst>
               <a:ext uri="{FF2B5EF4-FFF2-40B4-BE49-F238E27FC236}">
-                <a16:creationId xmlns:a16="http://schemas.microsoft.com/office/drawing/2014/main" id="{56A89710-1B01-FA6B-7CE3-6B245217D151}"/>
+                <a16:creationId xmlns:a16="http://schemas.microsoft.com/office/drawing/2014/main" id="{084BBFD7-18B3-98B0-3045-3067BBA127E7}"/>
               </a:ext>
             </a:extLst>
           </p:cNvPr>
@@ -3783,7 +3783,7 @@
           <p:cNvPr id="5" name="Date Placeholder 4">
             <a:extLst>
               <a:ext uri="{FF2B5EF4-FFF2-40B4-BE49-F238E27FC236}">
-                <a16:creationId xmlns:a16="http://schemas.microsoft.com/office/drawing/2014/main" id="{2601C197-ABB7-54AD-1E79-478E0546F7D9}"/>
+                <a16:creationId xmlns:a16="http://schemas.microsoft.com/office/drawing/2014/main" id="{73994DA9-8C28-8E1A-451D-4CFCB501D3FF}"/>
               </a:ext>
             </a:extLst>
           </p:cNvPr>
@@ -3799,7 +3799,7 @@
           <a:bodyPr/>
           <a:lstStyle/>
           <a:p>
-            <a:fld id="{68CF13B9-D35D-41F1-BDF9-F94BA176E306}" type="datetimeFigureOut">
+            <a:fld id="{1A83E605-C476-4F45-AFD5-5AA281B68665}" type="datetimeFigureOut">
               <a:rPr lang="en-US" smtClean="0"/>
               <a:t>10/26/2026</a:t>
             </a:fld>
@@ -3812,7 +3812,7 @@
           <p:cNvPr id="6" name="Footer Placeholder 5">
             <a:extLst>
               <a:ext uri="{FF2B5EF4-FFF2-40B4-BE49-F238E27FC236}">
-                <a16:creationId xmlns:a16="http://schemas.microsoft.com/office/drawing/2014/main" id="{2DB6E279-E0AB-4040-A946-B5181FFFE7D4}"/>
+                <a16:creationId xmlns:a16="http://schemas.microsoft.com/office/drawing/2014/main" id="{BE605FA3-3351-5E4F-9A2E-7698EA4DF2B2}"/>
               </a:ext>
             </a:extLst>
           </p:cNvPr>
@@ -3837,7 +3837,7 @@
           <p:cNvPr id="7" name="Slide Number Placeholder 6">
             <a:extLst>
               <a:ext uri="{FF2B5EF4-FFF2-40B4-BE49-F238E27FC236}">
-                <a16:creationId xmlns:a16="http://schemas.microsoft.com/office/drawing/2014/main" id="{00420525-9DFF-311F-63EF-5E743AA9FA86}"/>
+                <a16:creationId xmlns:a16="http://schemas.microsoft.com/office/drawing/2014/main" id="{1961DF0A-DB82-165C-7ADF-B2E79CB71E1B}"/>
               </a:ext>
             </a:extLst>
           </p:cNvPr>
@@ -3853,7 +3853,7 @@
           <a:bodyPr/>
           <a:lstStyle/>
           <a:p>
-            <a:fld id="{3D843947-BC9A-457D-B935-8A90E729CDD9}" type="slidenum">
+            <a:fld id="{D1BC5639-7327-40EC-ADEE-32BCFEE5F9FC}" type="slidenum">
               <a:rPr lang="en-US" smtClean="0"/>
               <a:t>‹#›</a:t>
             </a:fld>
@@ -3864,7 +3864,7 @@
     </p:spTree>
     <p:extLst>
       <p:ext uri="{BB962C8B-B14F-4D97-AF65-F5344CB8AC3E}">
-        <p14:creationId xmlns:p14="http://schemas.microsoft.com/office/powerpoint/2010/main" val="2268883808"/>
+        <p14:creationId xmlns:p14="http://schemas.microsoft.com/office/powerpoint/2010/main" val="183405005"/>
       </p:ext>
     </p:extLst>
   </p:cSld>
@@ -3896,7 +3896,7 @@
           <p:cNvPr id="2" name="Title 1">
             <a:extLst>
               <a:ext uri="{FF2B5EF4-FFF2-40B4-BE49-F238E27FC236}">
-                <a16:creationId xmlns:a16="http://schemas.microsoft.com/office/drawing/2014/main" id="{23B6CD84-8DC7-328F-2989-7EC44D6B4AB1}"/>
+                <a16:creationId xmlns:a16="http://schemas.microsoft.com/office/drawing/2014/main" id="{0F65378C-4ED0-56AB-BAC7-C0B994FABC6E}"/>
               </a:ext>
             </a:extLst>
           </p:cNvPr>
@@ -3933,7 +3933,7 @@
           <p:cNvPr id="3" name="Picture Placeholder 2">
             <a:extLst>
               <a:ext uri="{FF2B5EF4-FFF2-40B4-BE49-F238E27FC236}">
-                <a16:creationId xmlns:a16="http://schemas.microsoft.com/office/drawing/2014/main" id="{938C4582-2A7D-3317-E1E7-45FE75B57F9D}"/>
+                <a16:creationId xmlns:a16="http://schemas.microsoft.com/office/drawing/2014/main" id="{D4CD82A8-778A-6CBD-62EB-B0020E74F9CB}"/>
               </a:ext>
             </a:extLst>
           </p:cNvPr>
@@ -4000,7 +4000,7 @@
           <p:cNvPr id="4" name="Text Placeholder 3">
             <a:extLst>
               <a:ext uri="{FF2B5EF4-FFF2-40B4-BE49-F238E27FC236}">
-                <a16:creationId xmlns:a16="http://schemas.microsoft.com/office/drawing/2014/main" id="{2A31B522-6035-B12B-C1DE-235B597A8F58}"/>
+                <a16:creationId xmlns:a16="http://schemas.microsoft.com/office/drawing/2014/main" id="{8A5C98BD-5856-FAB6-1738-4F974C81A8C3}"/>
               </a:ext>
             </a:extLst>
           </p:cNvPr>
@@ -4071,7 +4071,7 @@
           <p:cNvPr id="5" name="Date Placeholder 4">
             <a:extLst>
               <a:ext uri="{FF2B5EF4-FFF2-40B4-BE49-F238E27FC236}">
-                <a16:creationId xmlns:a16="http://schemas.microsoft.com/office/drawing/2014/main" id="{71580841-F670-37FC-4D57-79113C76E725}"/>
+                <a16:creationId xmlns:a16="http://schemas.microsoft.com/office/drawing/2014/main" id="{266FD333-B15F-BBA1-0FDF-6E51009818FE}"/>
               </a:ext>
             </a:extLst>
           </p:cNvPr>
@@ -4087,7 +4087,7 @@
           <a:bodyPr/>
           <a:lstStyle/>
           <a:p>
-            <a:fld id="{68CF13B9-D35D-41F1-BDF9-F94BA176E306}" type="datetimeFigureOut">
+            <a:fld id="{1A83E605-C476-4F45-AFD5-5AA281B68665}" type="datetimeFigureOut">
               <a:rPr lang="en-US" smtClean="0"/>
               <a:t>10/26/2026</a:t>
             </a:fld>
@@ -4100,7 +4100,7 @@
           <p:cNvPr id="6" name="Footer Placeholder 5">
             <a:extLst>
               <a:ext uri="{FF2B5EF4-FFF2-40B4-BE49-F238E27FC236}">
-                <a16:creationId xmlns:a16="http://schemas.microsoft.com/office/drawing/2014/main" id="{8BEE1BEB-5DB3-AE14-8DB1-44F7DC7824E4}"/>
+                <a16:creationId xmlns:a16="http://schemas.microsoft.com/office/drawing/2014/main" id="{21ABA3A4-F266-9BFB-BC1B-1406A6126074}"/>
               </a:ext>
             </a:extLst>
           </p:cNvPr>
@@ -4125,7 +4125,7 @@
           <p:cNvPr id="7" name="Slide Number Placeholder 6">
             <a:extLst>
               <a:ext uri="{FF2B5EF4-FFF2-40B4-BE49-F238E27FC236}">
-                <a16:creationId xmlns:a16="http://schemas.microsoft.com/office/drawing/2014/main" id="{8BDFDCB6-7AD9-9A1B-A762-EAE590F41934}"/>
+                <a16:creationId xmlns:a16="http://schemas.microsoft.com/office/drawing/2014/main" id="{380C9EC3-C7F1-8598-E22D-2FC793B82CB1}"/>
               </a:ext>
             </a:extLst>
           </p:cNvPr>
@@ -4141,7 +4141,7 @@
           <a:bodyPr/>
           <a:lstStyle/>
           <a:p>
-            <a:fld id="{3D843947-BC9A-457D-B935-8A90E729CDD9}" type="slidenum">
+            <a:fld id="{D1BC5639-7327-40EC-ADEE-32BCFEE5F9FC}" type="slidenum">
               <a:rPr lang="en-US" smtClean="0"/>
               <a:t>‹#›</a:t>
             </a:fld>
@@ -4152,7 +4152,7 @@
     </p:spTree>
     <p:extLst>
       <p:ext uri="{BB962C8B-B14F-4D97-AF65-F5344CB8AC3E}">
-        <p14:creationId xmlns:p14="http://schemas.microsoft.com/office/powerpoint/2010/main" val="3541287163"/>
+        <p14:creationId xmlns:p14="http://schemas.microsoft.com/office/powerpoint/2010/main" val="1317438128"/>
       </p:ext>
     </p:extLst>
   </p:cSld>
@@ -4189,7 +4189,7 @@
           <p:cNvPr id="2" name="Title Placeholder 1">
             <a:extLst>
               <a:ext uri="{FF2B5EF4-FFF2-40B4-BE49-F238E27FC236}">
-                <a16:creationId xmlns:a16="http://schemas.microsoft.com/office/drawing/2014/main" id="{7DD1EA86-CCA6-8C4B-930C-71BF84D6FD34}"/>
+                <a16:creationId xmlns:a16="http://schemas.microsoft.com/office/drawing/2014/main" id="{C9E5D7FE-070F-0169-7BA6-5C6A474B7C78}"/>
               </a:ext>
             </a:extLst>
           </p:cNvPr>
@@ -4227,7 +4227,7 @@
           <p:cNvPr id="3" name="Text Placeholder 2">
             <a:extLst>
               <a:ext uri="{FF2B5EF4-FFF2-40B4-BE49-F238E27FC236}">
-                <a16:creationId xmlns:a16="http://schemas.microsoft.com/office/drawing/2014/main" id="{15E1C665-5602-C505-47BC-326B48DA46F6}"/>
+                <a16:creationId xmlns:a16="http://schemas.microsoft.com/office/drawing/2014/main" id="{D995CC02-02F2-DE2D-F377-1D193091D886}"/>
               </a:ext>
             </a:extLst>
           </p:cNvPr>
@@ -4294,7 +4294,7 @@
           <p:cNvPr id="4" name="Date Placeholder 3">
             <a:extLst>
               <a:ext uri="{FF2B5EF4-FFF2-40B4-BE49-F238E27FC236}">
-                <a16:creationId xmlns:a16="http://schemas.microsoft.com/office/drawing/2014/main" id="{E2225076-57A8-3F30-531F-B6861A41E4EB}"/>
+                <a16:creationId xmlns:a16="http://schemas.microsoft.com/office/drawing/2014/main" id="{C0AFF0B9-34CC-A856-A180-344640C1D7A1}"/>
               </a:ext>
             </a:extLst>
           </p:cNvPr>
@@ -4328,7 +4328,7 @@
             </a:lvl1pPr>
           </a:lstStyle>
           <a:p>
-            <a:fld id="{68CF13B9-D35D-41F1-BDF9-F94BA176E306}" type="datetimeFigureOut">
+            <a:fld id="{1A83E605-C476-4F45-AFD5-5AA281B68665}" type="datetimeFigureOut">
               <a:rPr lang="en-US" smtClean="0"/>
               <a:t>10/26/2026</a:t>
             </a:fld>
@@ -4341,7 +4341,7 @@
           <p:cNvPr id="5" name="Footer Placeholder 4">
             <a:extLst>
               <a:ext uri="{FF2B5EF4-FFF2-40B4-BE49-F238E27FC236}">
-                <a16:creationId xmlns:a16="http://schemas.microsoft.com/office/drawing/2014/main" id="{C02F429A-CE62-6168-3108-BD958DD8B2E9}"/>
+                <a16:creationId xmlns:a16="http://schemas.microsoft.com/office/drawing/2014/main" id="{F959BC62-9109-DE7B-0BD0-A28C50E641CF}"/>
               </a:ext>
             </a:extLst>
           </p:cNvPr>
@@ -4384,7 +4384,7 @@
           <p:cNvPr id="6" name="Slide Number Placeholder 5">
             <a:extLst>
               <a:ext uri="{FF2B5EF4-FFF2-40B4-BE49-F238E27FC236}">
-                <a16:creationId xmlns:a16="http://schemas.microsoft.com/office/drawing/2014/main" id="{A582588C-3538-3834-CE38-C0BC710B52E2}"/>
+                <a16:creationId xmlns:a16="http://schemas.microsoft.com/office/drawing/2014/main" id="{D88FDC10-4643-9BAD-4FEE-28EAEB5ADB0B}"/>
               </a:ext>
             </a:extLst>
           </p:cNvPr>
@@ -4418,7 +4418,7 @@
             </a:lvl1pPr>
           </a:lstStyle>
           <a:p>
-            <a:fld id="{3D843947-BC9A-457D-B935-8A90E729CDD9}" type="slidenum">
+            <a:fld id="{D1BC5639-7327-40EC-ADEE-32BCFEE5F9FC}" type="slidenum">
               <a:rPr lang="en-US" smtClean="0"/>
               <a:t>‹#›</a:t>
             </a:fld>
@@ -4429,7 +4429,7 @@
     </p:spTree>
     <p:extLst>
       <p:ext uri="{BB962C8B-B14F-4D97-AF65-F5344CB8AC3E}">
-        <p14:creationId xmlns:p14="http://schemas.microsoft.com/office/powerpoint/2010/main" val="1446260024"/>
+        <p14:creationId xmlns:p14="http://schemas.microsoft.com/office/powerpoint/2010/main" val="3272210829"/>
       </p:ext>
     </p:extLst>
   </p:cSld>
@@ -4752,7 +4752,7 @@
           <p:cNvPr id="2" name="Title 1">
             <a:extLst>
               <a:ext uri="{FF2B5EF4-FFF2-40B4-BE49-F238E27FC236}">
-                <a16:creationId xmlns:a16="http://schemas.microsoft.com/office/drawing/2014/main" id="{2B34A75C-3271-AAA6-C7A7-9138B6EDA0D6}"/>
+                <a16:creationId xmlns:a16="http://schemas.microsoft.com/office/drawing/2014/main" id="{78B230D0-E92A-02F5-361E-6F40648A144D}"/>
               </a:ext>
             </a:extLst>
           </p:cNvPr>
@@ -4780,7 +4780,7 @@
           <p:cNvPr id="3" name="Subtitle 2">
             <a:extLst>
               <a:ext uri="{FF2B5EF4-FFF2-40B4-BE49-F238E27FC236}">
-                <a16:creationId xmlns:a16="http://schemas.microsoft.com/office/drawing/2014/main" id="{A3527BA2-19E1-850A-92A0-E32FE39C6D8E}"/>
+                <a16:creationId xmlns:a16="http://schemas.microsoft.com/office/drawing/2014/main" id="{37F82741-EAAE-06CD-05FB-DD7CECFF7F84}"/>
               </a:ext>
             </a:extLst>
           </p:cNvPr>
@@ -4806,7 +4806,7 @@
     </p:spTree>
     <p:extLst>
       <p:ext uri="{BB962C8B-B14F-4D97-AF65-F5344CB8AC3E}">
-        <p14:creationId xmlns:p14="http://schemas.microsoft.com/office/powerpoint/2010/main" val="3602424947"/>
+        <p14:creationId xmlns:p14="http://schemas.microsoft.com/office/powerpoint/2010/main" val="3317420512"/>
       </p:ext>
     </p:extLst>
   </p:cSld>
@@ -4838,7 +4838,7 @@
           <p:cNvPr id="2" name="Title 1">
             <a:extLst>
               <a:ext uri="{FF2B5EF4-FFF2-40B4-BE49-F238E27FC236}">
-                <a16:creationId xmlns:a16="http://schemas.microsoft.com/office/drawing/2014/main" id="{9ACEEDED-5B6F-6700-E22E-551A94B0B1B7}"/>
+                <a16:creationId xmlns:a16="http://schemas.microsoft.com/office/drawing/2014/main" id="{366F9C93-A5A9-43C9-7DF9-8B1ECA7058B3}"/>
               </a:ext>
             </a:extLst>
           </p:cNvPr>
@@ -4864,7 +4864,7 @@
     </p:spTree>
     <p:extLst>
       <p:ext uri="{BB962C8B-B14F-4D97-AF65-F5344CB8AC3E}">
-        <p14:creationId xmlns:p14="http://schemas.microsoft.com/office/powerpoint/2010/main" val="153776142"/>
+        <p14:creationId xmlns:p14="http://schemas.microsoft.com/office/powerpoint/2010/main" val="3790154619"/>
       </p:ext>
     </p:extLst>
   </p:cSld>
@@ -4896,7 +4896,7 @@
           <p:cNvPr id="2" name="Title 1">
             <a:extLst>
               <a:ext uri="{FF2B5EF4-FFF2-40B4-BE49-F238E27FC236}">
-                <a16:creationId xmlns:a16="http://schemas.microsoft.com/office/drawing/2014/main" id="{1751B85A-8CEF-A23E-F86B-952B9FBC480A}"/>
+                <a16:creationId xmlns:a16="http://schemas.microsoft.com/office/drawing/2014/main" id="{5E16212E-28E1-01B3-804C-44B547C5E5A0}"/>
               </a:ext>
             </a:extLst>
           </p:cNvPr>
@@ -4929,7 +4929,7 @@
           <p:cNvPr id="3" name="Content Placeholder 2">
             <a:extLst>
               <a:ext uri="{FF2B5EF4-FFF2-40B4-BE49-F238E27FC236}">
-                <a16:creationId xmlns:a16="http://schemas.microsoft.com/office/drawing/2014/main" id="{2D8500AB-1C26-57BD-CC92-12D6715E3E40}"/>
+                <a16:creationId xmlns:a16="http://schemas.microsoft.com/office/drawing/2014/main" id="{E3B0D193-7903-646B-BBC3-A933BAACEF80}"/>
               </a:ext>
             </a:extLst>
           </p:cNvPr>
@@ -4968,7 +4968,7 @@
     </p:spTree>
     <p:extLst>
       <p:ext uri="{BB962C8B-B14F-4D97-AF65-F5344CB8AC3E}">
-        <p14:creationId xmlns:p14="http://schemas.microsoft.com/office/powerpoint/2010/main" val="2546505160"/>
+        <p14:creationId xmlns:p14="http://schemas.microsoft.com/office/powerpoint/2010/main" val="3269533684"/>
       </p:ext>
     </p:extLst>
   </p:cSld>
@@ -5000,7 +5000,7 @@
           <p:cNvPr id="2" name="Title 1">
             <a:extLst>
               <a:ext uri="{FF2B5EF4-FFF2-40B4-BE49-F238E27FC236}">
-                <a16:creationId xmlns:a16="http://schemas.microsoft.com/office/drawing/2014/main" id="{AD5D0212-05C8-8E71-CA29-1DCD8442C3F6}"/>
+                <a16:creationId xmlns:a16="http://schemas.microsoft.com/office/drawing/2014/main" id="{59996AEB-D995-C40D-CE35-8ACDE55082A8}"/>
               </a:ext>
             </a:extLst>
           </p:cNvPr>
@@ -5028,7 +5028,7 @@
           <p:cNvPr id="3" name="SalesChart">
             <a:extLst>
               <a:ext uri="{FF2B5EF4-FFF2-40B4-BE49-F238E27FC236}">
-                <a16:creationId xmlns:a16="http://schemas.microsoft.com/office/drawing/2014/main" id="{45E9FDB6-A515-5874-10F4-FA6F2D646F09}"/>
+                <a16:creationId xmlns:a16="http://schemas.microsoft.com/office/drawing/2014/main" id="{F1415FC3-2288-03A5-2ABC-39B46D57D5F0}"/>
               </a:ext>
             </a:extLst>
           </p:cNvPr>
@@ -5036,7 +5036,7 @@
           <p:nvPr>
             <p:extLst>
               <p:ext uri="{D42A27DB-BD31-4B8C-83A1-F6EECF244321}">
-                <p14:modId xmlns:p14="http://schemas.microsoft.com/office/powerpoint/2010/main" val="3500124069"/>
+                <p14:modId xmlns:p14="http://schemas.microsoft.com/office/powerpoint/2010/main" val="245364669"/>
               </p:ext>
             </p:extLst>
           </p:nvPr>
@@ -5054,7 +5054,7 @@
     </p:spTree>
     <p:extLst>
       <p:ext uri="{BB962C8B-B14F-4D97-AF65-F5344CB8AC3E}">
-        <p14:creationId xmlns:p14="http://schemas.microsoft.com/office/powerpoint/2010/main" val="654401342"/>
+        <p14:creationId xmlns:p14="http://schemas.microsoft.com/office/powerpoint/2010/main" val="1953062559"/>
       </p:ext>
     </p:extLst>
   </p:cSld>
@@ -5086,7 +5086,7 @@
           <p:cNvPr id="2" name="Title 1">
             <a:extLst>
               <a:ext uri="{FF2B5EF4-FFF2-40B4-BE49-F238E27FC236}">
-                <a16:creationId xmlns:a16="http://schemas.microsoft.com/office/drawing/2014/main" id="{C8490BCC-936B-0450-8998-E6D8B7129AB2}"/>
+                <a16:creationId xmlns:a16="http://schemas.microsoft.com/office/drawing/2014/main" id="{6C49C633-BE54-B7B0-90C7-A083E5F9BCCA}"/>
               </a:ext>
             </a:extLst>
           </p:cNvPr>
@@ -5114,7 +5114,7 @@
           <p:cNvPr id="3" name="Content Placeholder 2">
             <a:extLst>
               <a:ext uri="{FF2B5EF4-FFF2-40B4-BE49-F238E27FC236}">
-                <a16:creationId xmlns:a16="http://schemas.microsoft.com/office/drawing/2014/main" id="{C4E29B98-EF92-E554-CED9-6A310052B217}"/>
+                <a16:creationId xmlns:a16="http://schemas.microsoft.com/office/drawing/2014/main" id="{10CAE2DD-F966-9200-DD9C-71560CF46ABD}"/>
               </a:ext>
             </a:extLst>
           </p:cNvPr>
@@ -5167,7 +5167,7 @@
     </p:spTree>
     <p:extLst>
       <p:ext uri="{BB962C8B-B14F-4D97-AF65-F5344CB8AC3E}">
-        <p14:creationId xmlns:p14="http://schemas.microsoft.com/office/powerpoint/2010/main" val="3996755363"/>
+        <p14:creationId xmlns:p14="http://schemas.microsoft.com/office/powerpoint/2010/main" val="3721458526"/>
       </p:ext>
     </p:extLst>
   </p:cSld>
@@ -5199,7 +5199,7 @@
           <p:cNvPr id="2" name="Title 1">
             <a:extLst>
               <a:ext uri="{FF2B5EF4-FFF2-40B4-BE49-F238E27FC236}">
-                <a16:creationId xmlns:a16="http://schemas.microsoft.com/office/drawing/2014/main" id="{534051B4-319B-9088-B72F-6F520896F904}"/>
+                <a16:creationId xmlns:a16="http://schemas.microsoft.com/office/drawing/2014/main" id="{85313E60-929D-21EB-9300-83F49CBDEFD0}"/>
               </a:ext>
             </a:extLst>
           </p:cNvPr>
@@ -5227,7 +5227,7 @@
           <p:cNvPr id="3" name="Content Placeholder 2">
             <a:extLst>
               <a:ext uri="{FF2B5EF4-FFF2-40B4-BE49-F238E27FC236}">
-                <a16:creationId xmlns:a16="http://schemas.microsoft.com/office/drawing/2014/main" id="{CC4972BB-8426-C781-83B5-F57B800F475B}"/>
+                <a16:creationId xmlns:a16="http://schemas.microsoft.com/office/drawing/2014/main" id="{D62D1A62-2F4F-5EB5-2F2D-084402FABB24}"/>
               </a:ext>
             </a:extLst>
           </p:cNvPr>
@@ -5261,7 +5261,7 @@
           <p:cNvPr id="4" name="Content Placeholder 3">
             <a:extLst>
               <a:ext uri="{FF2B5EF4-FFF2-40B4-BE49-F238E27FC236}">
-                <a16:creationId xmlns:a16="http://schemas.microsoft.com/office/drawing/2014/main" id="{0EAE5CEC-70F4-316B-364B-DC534A461EBD}"/>
+                <a16:creationId xmlns:a16="http://schemas.microsoft.com/office/drawing/2014/main" id="{EC863452-62B0-47B5-8D41-4D6332019DA9}"/>
               </a:ext>
             </a:extLst>
           </p:cNvPr>
@@ -5293,7 +5293,7 @@
     </p:spTree>
     <p:extLst>
       <p:ext uri="{BB962C8B-B14F-4D97-AF65-F5344CB8AC3E}">
-        <p14:creationId xmlns:p14="http://schemas.microsoft.com/office/powerpoint/2010/main" val="3327576598"/>
+        <p14:creationId xmlns:p14="http://schemas.microsoft.com/office/powerpoint/2010/main" val="3515549419"/>
       </p:ext>
     </p:extLst>
   </p:cSld>
@@ -5325,7 +5325,7 @@
           <p:cNvPr id="2" name="Title 1">
             <a:extLst>
               <a:ext uri="{FF2B5EF4-FFF2-40B4-BE49-F238E27FC236}">
-                <a16:creationId xmlns:a16="http://schemas.microsoft.com/office/drawing/2014/main" id="{AC2FD598-89D5-2C45-C1A2-AC8E6D8A6114}"/>
+                <a16:creationId xmlns:a16="http://schemas.microsoft.com/office/drawing/2014/main" id="{46A931F9-612B-042F-8754-84889A69895C}"/>
               </a:ext>
             </a:extLst>
           </p:cNvPr>
@@ -5353,7 +5353,7 @@
           <p:cNvPr id="4" name="PlainPicture">
             <a:extLst>
               <a:ext uri="{FF2B5EF4-FFF2-40B4-BE49-F238E27FC236}">
-                <a16:creationId xmlns:a16="http://schemas.microsoft.com/office/drawing/2014/main" id="{9D515AE0-A497-5C76-57CE-29436F16B5EF}"/>
+                <a16:creationId xmlns:a16="http://schemas.microsoft.com/office/drawing/2014/main" id="{2A729752-2AC9-BFD3-C2CE-8E807285C9F6}"/>
               </a:ext>
             </a:extLst>
           </p:cNvPr>
@@ -5389,7 +5389,7 @@
           <p:cNvPr id="6" name="CroppedPicture">
             <a:extLst>
               <a:ext uri="{FF2B5EF4-FFF2-40B4-BE49-F238E27FC236}">
-                <a16:creationId xmlns:a16="http://schemas.microsoft.com/office/drawing/2014/main" id="{7B05E84C-E083-CECC-200D-A0412427E954}"/>
+                <a16:creationId xmlns:a16="http://schemas.microsoft.com/office/drawing/2014/main" id="{DE93B8A9-D62B-E9E5-DAA4-876FE913E4D5}"/>
               </a:ext>
             </a:extLst>
           </p:cNvPr>
@@ -5424,7 +5424,7 @@
     </p:spTree>
     <p:extLst>
       <p:ext uri="{BB962C8B-B14F-4D97-AF65-F5344CB8AC3E}">
-        <p14:creationId xmlns:p14="http://schemas.microsoft.com/office/powerpoint/2010/main" val="3979932502"/>
+        <p14:creationId xmlns:p14="http://schemas.microsoft.com/office/powerpoint/2010/main" val="1393763402"/>
       </p:ext>
     </p:extLst>
   </p:cSld>
@@ -5456,7 +5456,7 @@
           <p:cNvPr id="2" name="Title 1">
             <a:extLst>
               <a:ext uri="{FF2B5EF4-FFF2-40B4-BE49-F238E27FC236}">
-                <a16:creationId xmlns:a16="http://schemas.microsoft.com/office/drawing/2014/main" id="{97A9CB75-6C26-FC1A-2712-5AEC4CBBB847}"/>
+                <a16:creationId xmlns:a16="http://schemas.microsoft.com/office/drawing/2014/main" id="{4E7CFE67-6870-448D-0422-771AEF6F73B2}"/>
               </a:ext>
             </a:extLst>
           </p:cNvPr>
@@ -5484,7 +5484,7 @@
           <p:cNvPr id="3" name="MergedTable">
             <a:extLst>
               <a:ext uri="{FF2B5EF4-FFF2-40B4-BE49-F238E27FC236}">
-                <a16:creationId xmlns:a16="http://schemas.microsoft.com/office/drawing/2014/main" id="{2FA05CC0-B41D-F95F-D2D6-9EE3E6FCB040}"/>
+                <a16:creationId xmlns:a16="http://schemas.microsoft.com/office/drawing/2014/main" id="{548244D1-4670-448F-B246-9DF92D43CD78}"/>
               </a:ext>
             </a:extLst>
           </p:cNvPr>
@@ -5494,7 +5494,7 @@
           <p:nvPr>
             <p:extLst>
               <p:ext uri="{D42A27DB-BD31-4B8C-83A1-F6EECF244321}">
-                <p14:modId xmlns:p14="http://schemas.microsoft.com/office/powerpoint/2010/main" val="2740090705"/>
+                <p14:modId xmlns:p14="http://schemas.microsoft.com/office/powerpoint/2010/main" val="350163850"/>
               </p:ext>
             </p:extLst>
           </p:nvPr>
@@ -5513,28 +5513,28 @@
                 <a:gridCol w="2667000">
                   <a:extLst>
                     <a:ext uri="{9D8B030D-6E8A-4147-A177-3AD203B41FA5}">
-                      <a16:colId xmlns:a16="http://schemas.microsoft.com/office/drawing/2014/main" val="2164616358"/>
+                      <a16:colId xmlns:a16="http://schemas.microsoft.com/office/drawing/2014/main" val="80045205"/>
                     </a:ext>
                   </a:extLst>
                 </a:gridCol>
                 <a:gridCol w="2667000">
                   <a:extLst>
                     <a:ext uri="{9D8B030D-6E8A-4147-A177-3AD203B41FA5}">
-                      <a16:colId xmlns:a16="http://schemas.microsoft.com/office/drawing/2014/main" val="598586492"/>
+                      <a16:colId xmlns:a16="http://schemas.microsoft.com/office/drawing/2014/main" val="598683909"/>
                     </a:ext>
                   </a:extLst>
                 </a:gridCol>
                 <a:gridCol w="2667000">
                   <a:extLst>
                     <a:ext uri="{9D8B030D-6E8A-4147-A177-3AD203B41FA5}">
-                      <a16:colId xmlns:a16="http://schemas.microsoft.com/office/drawing/2014/main" val="2085842401"/>
+                      <a16:colId xmlns:a16="http://schemas.microsoft.com/office/drawing/2014/main" val="3971657670"/>
                     </a:ext>
                   </a:extLst>
                 </a:gridCol>
                 <a:gridCol w="2667000">
                   <a:extLst>
                     <a:ext uri="{9D8B030D-6E8A-4147-A177-3AD203B41FA5}">
-                      <a16:colId xmlns:a16="http://schemas.microsoft.com/office/drawing/2014/main" val="1228706172"/>
+                      <a16:colId xmlns:a16="http://schemas.microsoft.com/office/drawing/2014/main" val="3646065450"/>
                     </a:ext>
                   </a:extLst>
                 </a:gridCol>
@@ -5597,7 +5597,7 @@
                 </a:tc>
                 <a:extLst>
                   <a:ext uri="{0D108BD9-81ED-4DB2-BD59-A6C34878D82A}">
-                    <a16:rowId xmlns:a16="http://schemas.microsoft.com/office/drawing/2014/main" val="3091448558"/>
+                    <a16:rowId xmlns:a16="http://schemas.microsoft.com/office/drawing/2014/main" val="2209010911"/>
                   </a:ext>
                 </a:extLst>
               </a:tr>
@@ -5662,7 +5662,7 @@
                 </a:tc>
                 <a:extLst>
                   <a:ext uri="{0D108BD9-81ED-4DB2-BD59-A6C34878D82A}">
-                    <a16:rowId xmlns:a16="http://schemas.microsoft.com/office/drawing/2014/main" val="3391535254"/>
+                    <a16:rowId xmlns:a16="http://schemas.microsoft.com/office/drawing/2014/main" val="2803418772"/>
                   </a:ext>
                 </a:extLst>
               </a:tr>
@@ -5718,7 +5718,7 @@
                 </a:tc>
                 <a:extLst>
                   <a:ext uri="{0D108BD9-81ED-4DB2-BD59-A6C34878D82A}">
-                    <a16:rowId xmlns:a16="http://schemas.microsoft.com/office/drawing/2014/main" val="2940191608"/>
+                    <a16:rowId xmlns:a16="http://schemas.microsoft.com/office/drawing/2014/main" val="1887463854"/>
                   </a:ext>
                 </a:extLst>
               </a:tr>
@@ -5729,7 +5729,7 @@
     </p:spTree>
     <p:extLst>
       <p:ext uri="{BB962C8B-B14F-4D97-AF65-F5344CB8AC3E}">
-        <p14:creationId xmlns:p14="http://schemas.microsoft.com/office/powerpoint/2010/main" val="3886935783"/>
+        <p14:creationId xmlns:p14="http://schemas.microsoft.com/office/powerpoint/2010/main" val="1368086240"/>
       </p:ext>
     </p:extLst>
   </p:cSld>
@@ -5761,7 +5761,7 @@
           <p:cNvPr id="2" name="Title 1">
             <a:extLst>
               <a:ext uri="{FF2B5EF4-FFF2-40B4-BE49-F238E27FC236}">
-                <a16:creationId xmlns:a16="http://schemas.microsoft.com/office/drawing/2014/main" id="{19D60CDF-22D1-FC99-625D-39802CDDC041}"/>
+                <a16:creationId xmlns:a16="http://schemas.microsoft.com/office/drawing/2014/main" id="{B355B338-BB7F-CFDD-0E86-33CF5A2B2483}"/>
               </a:ext>
             </a:extLst>
           </p:cNvPr>
@@ -5789,7 +5789,7 @@
           <p:cNvPr id="3" name="RectShape">
             <a:extLst>
               <a:ext uri="{FF2B5EF4-FFF2-40B4-BE49-F238E27FC236}">
-                <a16:creationId xmlns:a16="http://schemas.microsoft.com/office/drawing/2014/main" id="{9C1265DA-8B68-791E-E92F-C646DC9A211C}"/>
+                <a16:creationId xmlns:a16="http://schemas.microsoft.com/office/drawing/2014/main" id="{1D91904A-6F49-D425-BCA1-49090240E545}"/>
               </a:ext>
             </a:extLst>
           </p:cNvPr>
@@ -5850,7 +5850,7 @@
           <p:cNvPr id="4" name="EllipseShape">
             <a:extLst>
               <a:ext uri="{FF2B5EF4-FFF2-40B4-BE49-F238E27FC236}">
-                <a16:creationId xmlns:a16="http://schemas.microsoft.com/office/drawing/2014/main" id="{F3116C90-5E92-CAC4-49C1-80A13BCC5475}"/>
+                <a16:creationId xmlns:a16="http://schemas.microsoft.com/office/drawing/2014/main" id="{F937DF6A-D7C5-F90F-B225-E0EE73B32746}"/>
               </a:ext>
             </a:extLst>
           </p:cNvPr>
@@ -5907,7 +5907,7 @@
           <p:cNvPr id="5" name="RoundShape">
             <a:extLst>
               <a:ext uri="{FF2B5EF4-FFF2-40B4-BE49-F238E27FC236}">
-                <a16:creationId xmlns:a16="http://schemas.microsoft.com/office/drawing/2014/main" id="{297EB1C5-95AC-86A3-DACC-E80A761BC7EB}"/>
+                <a16:creationId xmlns:a16="http://schemas.microsoft.com/office/drawing/2014/main" id="{BB9C2B69-924F-4F3D-0F0C-EB8D1A2E42F1}"/>
               </a:ext>
             </a:extLst>
           </p:cNvPr>
@@ -5976,7 +5976,7 @@
     </p:spTree>
     <p:extLst>
       <p:ext uri="{BB962C8B-B14F-4D97-AF65-F5344CB8AC3E}">
-        <p14:creationId xmlns:p14="http://schemas.microsoft.com/office/powerpoint/2010/main" val="296660922"/>
+        <p14:creationId xmlns:p14="http://schemas.microsoft.com/office/powerpoint/2010/main" val="3563219550"/>
       </p:ext>
     </p:extLst>
   </p:cSld>
@@ -6008,7 +6008,7 @@
           <p:cNvPr id="2" name="Title 1">
             <a:extLst>
               <a:ext uri="{FF2B5EF4-FFF2-40B4-BE49-F238E27FC236}">
-                <a16:creationId xmlns:a16="http://schemas.microsoft.com/office/drawing/2014/main" id="{F14282EF-5F09-6D0F-D481-91B77D1BC67B}"/>
+                <a16:creationId xmlns:a16="http://schemas.microsoft.com/office/drawing/2014/main" id="{CF126C67-E297-5D9C-590A-3138634162F2}"/>
               </a:ext>
             </a:extLst>
           </p:cNvPr>
@@ -6036,7 +6036,7 @@
           <p:cNvPr id="5" name="TwoShapeGroup">
             <a:extLst>
               <a:ext uri="{FF2B5EF4-FFF2-40B4-BE49-F238E27FC236}">
-                <a16:creationId xmlns:a16="http://schemas.microsoft.com/office/drawing/2014/main" id="{B75F000C-22A1-6C29-3A74-BDBCFB9E736F}"/>
+                <a16:creationId xmlns:a16="http://schemas.microsoft.com/office/drawing/2014/main" id="{40197D4D-095B-2465-736F-C8EB38900003}"/>
               </a:ext>
             </a:extLst>
           </p:cNvPr>
@@ -6056,7 +6056,7 @@
             <p:cNvPr id="3" name="GA">
               <a:extLst>
                 <a:ext uri="{FF2B5EF4-FFF2-40B4-BE49-F238E27FC236}">
-                  <a16:creationId xmlns:a16="http://schemas.microsoft.com/office/drawing/2014/main" id="{289B0B3B-9AFB-F2D2-E4BE-0704E6A9DDC6}"/>
+                  <a16:creationId xmlns:a16="http://schemas.microsoft.com/office/drawing/2014/main" id="{AA33D299-A3C7-A418-727B-FC7DF0EDC70C}"/>
                 </a:ext>
               </a:extLst>
             </p:cNvPr>
@@ -6108,7 +6108,7 @@
             <p:cNvPr id="4" name="GB">
               <a:extLst>
                 <a:ext uri="{FF2B5EF4-FFF2-40B4-BE49-F238E27FC236}">
-                  <a16:creationId xmlns:a16="http://schemas.microsoft.com/office/drawing/2014/main" id="{FB340F3F-58BC-5275-3256-85A1756533F8}"/>
+                  <a16:creationId xmlns:a16="http://schemas.microsoft.com/office/drawing/2014/main" id="{16840360-55F0-F7AC-53F0-FDC12C2C287A}"/>
                 </a:ext>
               </a:extLst>
             </p:cNvPr>
@@ -6159,7 +6159,7 @@
     </p:spTree>
     <p:extLst>
       <p:ext uri="{BB962C8B-B14F-4D97-AF65-F5344CB8AC3E}">
-        <p14:creationId xmlns:p14="http://schemas.microsoft.com/office/powerpoint/2010/main" val="2155413985"/>
+        <p14:creationId xmlns:p14="http://schemas.microsoft.com/office/powerpoint/2010/main" val="2767225469"/>
       </p:ext>
     </p:extLst>
   </p:cSld>
@@ -6199,7 +6199,7 @@
           <p:cNvPr id="2" name="Title 1">
             <a:extLst>
               <a:ext uri="{FF2B5EF4-FFF2-40B4-BE49-F238E27FC236}">
-                <a16:creationId xmlns:a16="http://schemas.microsoft.com/office/drawing/2014/main" id="{EE0E1BC5-5D17-1E58-A6AE-BF89F9D413DB}"/>
+                <a16:creationId xmlns:a16="http://schemas.microsoft.com/office/drawing/2014/main" id="{167B62A8-26F9-59FE-3196-C25318ACFA28}"/>
               </a:ext>
             </a:extLst>
           </p:cNvPr>
@@ -6229,7 +6229,7 @@
     </p:spTree>
     <p:extLst>
       <p:ext uri="{BB962C8B-B14F-4D97-AF65-F5344CB8AC3E}">
-        <p14:creationId xmlns:p14="http://schemas.microsoft.com/office/powerpoint/2010/main" val="889341920"/>
+        <p14:creationId xmlns:p14="http://schemas.microsoft.com/office/powerpoint/2010/main" val="414738269"/>
       </p:ext>
     </p:extLst>
   </p:cSld>
@@ -6261,7 +6261,7 @@
           <p:cNvPr id="2" name="Title 1">
             <a:extLst>
               <a:ext uri="{FF2B5EF4-FFF2-40B4-BE49-F238E27FC236}">
-                <a16:creationId xmlns:a16="http://schemas.microsoft.com/office/drawing/2014/main" id="{528CAC27-00B1-9BB9-2B99-57D6EA16A92D}"/>
+                <a16:creationId xmlns:a16="http://schemas.microsoft.com/office/drawing/2014/main" id="{6C6E38A1-677A-7FCC-3BE4-9F42A09535D2}"/>
               </a:ext>
             </a:extLst>
           </p:cNvPr>
@@ -6289,7 +6289,7 @@
           <p:cNvPr id="3" name="Content Placeholder 2">
             <a:extLst>
               <a:ext uri="{FF2B5EF4-FFF2-40B4-BE49-F238E27FC236}">
-                <a16:creationId xmlns:a16="http://schemas.microsoft.com/office/drawing/2014/main" id="{1101DC27-8C19-F094-9A37-2CC18AE0A51C}"/>
+                <a16:creationId xmlns:a16="http://schemas.microsoft.com/office/drawing/2014/main" id="{84DD89AE-B275-BA9D-4B95-DEB446FCFCE8}"/>
               </a:ext>
             </a:extLst>
           </p:cNvPr>
@@ -6315,7 +6315,7 @@
     </p:spTree>
     <p:extLst>
       <p:ext uri="{BB962C8B-B14F-4D97-AF65-F5344CB8AC3E}">
-        <p14:creationId xmlns:p14="http://schemas.microsoft.com/office/powerpoint/2010/main" val="189446236"/>
+        <p14:creationId xmlns:p14="http://schemas.microsoft.com/office/powerpoint/2010/main" val="4181773016"/>
       </p:ext>
     </p:extLst>
   </p:cSld>

</xml_diff>